<commit_message>
Add Course 2 (mentoring) and Course 5 (AI literacy); build their decks and phone packs
- mentor-3day: 3-day in-person + 6-week online programme, the Visit Hand model,
  visit playbook (individual, cluster, field day, phone check-in; season and week
  plans; traffic-light caseload), app track ON/OFF with paper twins
- ai-literacy: 2-day phone course with a full no-phone path, Question Hand,
  Check Ladder, scam spotting, printable prompt and answer cards
- Point app references at the single Records book (Picked / Sold / Spent)
- Toolkit: replace emoji in the feedback method; Phone Keeper role note

Co-Authored-By: Claude Opus 5.5 <noreply@anthropic.com>
Claude-Session: https://claude.ai/code/session_01DVvirN1GL3YvgFnXUT6gyq
</commit_message>
<xml_diff>
--- a/courses/build/farmer-5day/F-D5.pptx
+++ b/courses/build/farmer-5day/F-D5.pptx
@@ -590,7 +590,7 @@
           <a:lstStyle/>
           <a:p>
             <a:r>
-              <a:t>[APP] twin: log the harvest in Records / Field Journal. Then the garden handover roster.</a:t>
+              <a:t>[APP] twin: log the harvest in Records → Picked. Then the garden handover roster.</a:t>
             </a:r>
           </a:p>
           <a:p/>
@@ -812,7 +812,7 @@
           <a:lstStyle/>
           <a:p>
             <a:r>
-              <a:t>Everyone writes their card's lines. [APP] twin: Finances → Money in / Money out, scan a till slip.</a:t>
+              <a:t>Everyone writes their card's lines. [APP] twin: Records → Sold and Spent; scan a till slip in a Spent entry.</a:t>
             </a:r>
           </a:p>
           <a:p/>

</xml_diff>